<commit_message>
implement all analysis code
</commit_message>
<xml_diff>
--- a/baaad-strategy.pptx
+++ b/baaad-strategy.pptx
@@ -20,6 +20,7 @@
     <p:sldId id="268" r:id="rId19"/>
     <p:sldId id="269" r:id="rId20"/>
     <p:sldId id="270" r:id="rId21"/>
+    <p:sldId id="271" r:id="rId22"/>
   </p:sldIdLst>
   <p:sldSz cx="12188952" cy="6858000" type="screen4x3"/>
   <p:notesSz cx="6858000" cy="9144000"/>
@@ -3537,550 +3538,514 @@
                   <a:srgbClr val="FFFBF0"/>
                 </a:solidFill>
               </a:rPr>
-              <a:t>How to Run the Simulation</a:t>
-            </a:r>
-          </a:p>
-        </p:txBody>
-      </p:sp>
-      <p:sp>
-        <p:nvSpPr>
-          <p:cNvPr id="4" name="Rectangle 3"/>
-          <p:cNvSpPr/>
+              <a:t>Simplifications vs. Full Catan Rules</a:t>
+            </a:r>
+          </a:p>
+        </p:txBody>
+      </p:sp>
+      <p:graphicFrame>
+        <p:nvGraphicFramePr>
+          <p:cNvPr id="4" name="Table 3"/>
+          <p:cNvGraphicFramePr>
+            <a:graphicFrameLocks noGrp="1"/>
+          </p:cNvGraphicFramePr>
           <p:nvPr/>
-        </p:nvSpPr>
-        <p:spPr>
-          <a:xfrm>
-            <a:off x="365760" y="1188720"/>
-            <a:ext cx="7772400" cy="2926080"/>
-          </a:xfrm>
-          <a:prstGeom prst="rect">
-            <a:avLst/>
-          </a:prstGeom>
-          <a:solidFill>
-            <a:srgbClr val="1A3D1A"/>
-          </a:solidFill>
-          <a:ln w="19050">
-            <a:solidFill>
-              <a:srgbClr val="8ECF3A"/>
-            </a:solidFill>
-          </a:ln>
-        </p:spPr>
-        <p:style>
-          <a:lnRef idx="1">
-            <a:schemeClr val="accent1"/>
-          </a:lnRef>
-          <a:fillRef idx="3">
-            <a:schemeClr val="accent1"/>
-          </a:fillRef>
-          <a:effectRef idx="2">
-            <a:schemeClr val="accent1"/>
-          </a:effectRef>
-          <a:fontRef idx="minor">
-            <a:schemeClr val="lt1"/>
-          </a:fontRef>
-        </p:style>
-        <p:txBody>
-          <a:bodyPr rtlCol="0" anchor="ctr"/>
-          <a:lstStyle/>
-          <a:p>
-            <a:pPr algn="ctr"/>
-          </a:p>
-        </p:txBody>
-      </p:sp>
-      <p:sp>
-        <p:nvSpPr>
-          <p:cNvPr id="5" name="TextBox 4"/>
-          <p:cNvSpPr txBox="1"/>
-          <p:nvPr/>
-        </p:nvSpPr>
-        <p:spPr>
-          <a:xfrm>
-            <a:off x="640080" y="1325880"/>
-            <a:ext cx="7315200" cy="2651760"/>
-          </a:xfrm>
-          <a:prstGeom prst="rect">
-            <a:avLst/>
-          </a:prstGeom>
-          <a:noFill/>
-        </p:spPr>
-        <p:txBody>
-          <a:bodyPr wrap="square">
-            <a:spAutoFit/>
-          </a:bodyPr>
-          <a:lstStyle/>
-          <a:p>
-            <a:pPr algn="l"/>
-            <a:r>
-              <a:rPr sz="1700" b="0" i="0">
-                <a:solidFill>
-                  <a:srgbClr val="8ECF3A"/>
-                </a:solidFill>
-              </a:rPr>
-              <a:t>source("R/simulation.R")
-results &lt;- run_simulation(
-    n_games = 1000,
-    seed    = 42
-)
-source("R/analysis.R")
-plot_win_rates(results)</a:t>
-            </a:r>
-          </a:p>
-        </p:txBody>
-      </p:sp>
-      <p:sp>
-        <p:nvSpPr>
-          <p:cNvPr id="6" name="Rectangle 5"/>
-          <p:cNvSpPr/>
-          <p:nvPr/>
-        </p:nvSpPr>
-        <p:spPr>
-          <a:xfrm>
-            <a:off x="8412480" y="1234440"/>
-            <a:ext cx="3383280" cy="1143000"/>
-          </a:xfrm>
-          <a:prstGeom prst="rect">
-            <a:avLst/>
-          </a:prstGeom>
-          <a:solidFill>
-            <a:srgbClr val="FFFBF0"/>
-          </a:solidFill>
-          <a:ln w="9525">
-            <a:solidFill>
-              <a:srgbClr val="CCCCBB"/>
-            </a:solidFill>
-          </a:ln>
-        </p:spPr>
-        <p:style>
-          <a:lnRef idx="1">
-            <a:schemeClr val="accent1"/>
-          </a:lnRef>
-          <a:fillRef idx="3">
-            <a:schemeClr val="accent1"/>
-          </a:fillRef>
-          <a:effectRef idx="2">
-            <a:schemeClr val="accent1"/>
-          </a:effectRef>
-          <a:fontRef idx="minor">
-            <a:schemeClr val="lt1"/>
-          </a:fontRef>
-        </p:style>
-        <p:txBody>
-          <a:bodyPr rtlCol="0" anchor="ctr"/>
-          <a:lstStyle/>
-          <a:p>
-            <a:pPr algn="ctr"/>
-          </a:p>
-        </p:txBody>
-      </p:sp>
-      <p:sp>
-        <p:nvSpPr>
-          <p:cNvPr id="7" name="TextBox 6"/>
-          <p:cNvSpPr txBox="1"/>
-          <p:nvPr/>
-        </p:nvSpPr>
-        <p:spPr>
-          <a:xfrm>
-            <a:off x="8549640" y="1307592"/>
-            <a:ext cx="3108960" cy="365760"/>
-          </a:xfrm>
-          <a:prstGeom prst="rect">
-            <a:avLst/>
-          </a:prstGeom>
-          <a:noFill/>
-        </p:spPr>
-        <p:txBody>
-          <a:bodyPr wrap="square">
-            <a:spAutoFit/>
-          </a:bodyPr>
-          <a:lstStyle/>
-          <a:p>
-            <a:pPr algn="l"/>
-            <a:r>
-              <a:rPr sz="1400" b="1" i="0">
-                <a:solidFill>
-                  <a:srgbClr val="1A3D1A"/>
-                </a:solidFill>
-              </a:rPr>
-              <a:t>Output</a:t>
-            </a:r>
-          </a:p>
-        </p:txBody>
-      </p:sp>
-      <p:sp>
-        <p:nvSpPr>
-          <p:cNvPr id="8" name="TextBox 7"/>
-          <p:cNvSpPr txBox="1"/>
-          <p:nvPr/>
-        </p:nvSpPr>
-        <p:spPr>
-          <a:xfrm>
-            <a:off x="8549640" y="1645920"/>
-            <a:ext cx="3108960" cy="640080"/>
-          </a:xfrm>
-          <a:prstGeom prst="rect">
-            <a:avLst/>
-          </a:prstGeom>
-          <a:noFill/>
-        </p:spPr>
-        <p:txBody>
-          <a:bodyPr wrap="square">
-            <a:spAutoFit/>
-          </a:bodyPr>
-          <a:lstStyle/>
-          <a:p>
-            <a:pPr algn="l"/>
-            <a:r>
-              <a:rPr sz="1300" b="0" i="0">
-                <a:solidFill>
-                  <a:srgbClr val="1A1A1A"/>
-                </a:solidFill>
-              </a:rPr>
-              <a:t>results/simulation_results.csv</a:t>
-            </a:r>
-          </a:p>
-        </p:txBody>
-      </p:sp>
-      <p:sp>
-        <p:nvSpPr>
-          <p:cNvPr id="9" name="Rectangle 8"/>
-          <p:cNvSpPr/>
-          <p:nvPr/>
-        </p:nvSpPr>
-        <p:spPr>
-          <a:xfrm>
-            <a:off x="8412480" y="2560320"/>
-            <a:ext cx="3383280" cy="1143000"/>
-          </a:xfrm>
-          <a:prstGeom prst="rect">
-            <a:avLst/>
-          </a:prstGeom>
-          <a:solidFill>
-            <a:srgbClr val="FFFBF0"/>
-          </a:solidFill>
-          <a:ln w="9525">
-            <a:solidFill>
-              <a:srgbClr val="CCCCBB"/>
-            </a:solidFill>
-          </a:ln>
-        </p:spPr>
-        <p:style>
-          <a:lnRef idx="1">
-            <a:schemeClr val="accent1"/>
-          </a:lnRef>
-          <a:fillRef idx="3">
-            <a:schemeClr val="accent1"/>
-          </a:fillRef>
-          <a:effectRef idx="2">
-            <a:schemeClr val="accent1"/>
-          </a:effectRef>
-          <a:fontRef idx="minor">
-            <a:schemeClr val="lt1"/>
-          </a:fontRef>
-        </p:style>
-        <p:txBody>
-          <a:bodyPr rtlCol="0" anchor="ctr"/>
-          <a:lstStyle/>
-          <a:p>
-            <a:pPr algn="ctr"/>
-          </a:p>
-        </p:txBody>
-      </p:sp>
-      <p:sp>
-        <p:nvSpPr>
-          <p:cNvPr id="10" name="TextBox 9"/>
-          <p:cNvSpPr txBox="1"/>
-          <p:nvPr/>
-        </p:nvSpPr>
-        <p:spPr>
-          <a:xfrm>
-            <a:off x="8549640" y="2633472"/>
-            <a:ext cx="3108960" cy="365760"/>
-          </a:xfrm>
-          <a:prstGeom prst="rect">
-            <a:avLst/>
-          </a:prstGeom>
-          <a:noFill/>
-        </p:spPr>
-        <p:txBody>
-          <a:bodyPr wrap="square">
-            <a:spAutoFit/>
-          </a:bodyPr>
-          <a:lstStyle/>
-          <a:p>
-            <a:pPr algn="l"/>
-            <a:r>
-              <a:rPr sz="1400" b="1" i="0">
-                <a:solidFill>
-                  <a:srgbClr val="1A3D1A"/>
-                </a:solidFill>
-              </a:rPr>
-              <a:t>Charts</a:t>
-            </a:r>
-          </a:p>
-        </p:txBody>
-      </p:sp>
-      <p:sp>
-        <p:nvSpPr>
-          <p:cNvPr id="11" name="TextBox 10"/>
-          <p:cNvSpPr txBox="1"/>
-          <p:nvPr/>
-        </p:nvSpPr>
-        <p:spPr>
-          <a:xfrm>
-            <a:off x="8549640" y="2971800"/>
-            <a:ext cx="3108960" cy="640080"/>
-          </a:xfrm>
-          <a:prstGeom prst="rect">
-            <a:avLst/>
-          </a:prstGeom>
-          <a:noFill/>
-        </p:spPr>
-        <p:txBody>
-          <a:bodyPr wrap="square">
-            <a:spAutoFit/>
-          </a:bodyPr>
-          <a:lstStyle/>
-          <a:p>
-            <a:pPr algn="l"/>
-            <a:r>
-              <a:rPr sz="1300" b="0" i="0">
-                <a:solidFill>
-                  <a:srgbClr val="1A1A1A"/>
-                </a:solidFill>
-              </a:rPr>
-              <a:t>Win rate bar chart with 95% CIs
-VP distribution violin/boxplot</a:t>
-            </a:r>
-          </a:p>
-        </p:txBody>
-      </p:sp>
-      <p:sp>
-        <p:nvSpPr>
-          <p:cNvPr id="12" name="Rectangle 11"/>
-          <p:cNvSpPr/>
-          <p:nvPr/>
-        </p:nvSpPr>
-        <p:spPr>
-          <a:xfrm>
-            <a:off x="8412480" y="3886200"/>
-            <a:ext cx="3383280" cy="1143000"/>
-          </a:xfrm>
-          <a:prstGeom prst="rect">
-            <a:avLst/>
-          </a:prstGeom>
-          <a:solidFill>
-            <a:srgbClr val="FFFBF0"/>
-          </a:solidFill>
-          <a:ln w="9525">
-            <a:solidFill>
-              <a:srgbClr val="CCCCBB"/>
-            </a:solidFill>
-          </a:ln>
-        </p:spPr>
-        <p:style>
-          <a:lnRef idx="1">
-            <a:schemeClr val="accent1"/>
-          </a:lnRef>
-          <a:fillRef idx="3">
-            <a:schemeClr val="accent1"/>
-          </a:fillRef>
-          <a:effectRef idx="2">
-            <a:schemeClr val="accent1"/>
-          </a:effectRef>
-          <a:fontRef idx="minor">
-            <a:schemeClr val="lt1"/>
-          </a:fontRef>
-        </p:style>
-        <p:txBody>
-          <a:bodyPr rtlCol="0" anchor="ctr"/>
-          <a:lstStyle/>
-          <a:p>
-            <a:pPr algn="ctr"/>
-          </a:p>
-        </p:txBody>
-      </p:sp>
-      <p:sp>
-        <p:nvSpPr>
-          <p:cNvPr id="13" name="TextBox 12"/>
-          <p:cNvSpPr txBox="1"/>
-          <p:nvPr/>
-        </p:nvSpPr>
-        <p:spPr>
-          <a:xfrm>
-            <a:off x="8549640" y="3959352"/>
-            <a:ext cx="3108960" cy="365760"/>
-          </a:xfrm>
-          <a:prstGeom prst="rect">
-            <a:avLst/>
-          </a:prstGeom>
-          <a:noFill/>
-        </p:spPr>
-        <p:txBody>
-          <a:bodyPr wrap="square">
-            <a:spAutoFit/>
-          </a:bodyPr>
-          <a:lstStyle/>
-          <a:p>
-            <a:pPr algn="l"/>
-            <a:r>
-              <a:rPr sz="1400" b="1" i="0">
-                <a:solidFill>
-                  <a:srgbClr val="1A3D1A"/>
-                </a:solidFill>
-              </a:rPr>
-              <a:t>Stats</a:t>
-            </a:r>
-          </a:p>
-        </p:txBody>
-      </p:sp>
-      <p:sp>
-        <p:nvSpPr>
-          <p:cNvPr id="14" name="TextBox 13"/>
-          <p:cNvSpPr txBox="1"/>
-          <p:nvPr/>
-        </p:nvSpPr>
-        <p:spPr>
-          <a:xfrm>
-            <a:off x="8549640" y="4297680"/>
-            <a:ext cx="3108960" cy="640080"/>
-          </a:xfrm>
-          <a:prstGeom prst="rect">
-            <a:avLst/>
-          </a:prstGeom>
-          <a:noFill/>
-        </p:spPr>
-        <p:txBody>
-          <a:bodyPr wrap="square">
-            <a:spAutoFit/>
-          </a:bodyPr>
-          <a:lstStyle/>
-          <a:p>
-            <a:pPr algn="l"/>
-            <a:r>
-              <a:rPr sz="1300" b="0" i="0">
-                <a:solidFill>
-                  <a:srgbClr val="1A1A1A"/>
-                </a:solidFill>
-              </a:rPr>
-              <a:t>χ² test on win-count table
-Target: p &lt; 0.05</a:t>
-            </a:r>
-          </a:p>
-        </p:txBody>
-      </p:sp>
-      <p:sp>
-        <p:nvSpPr>
-          <p:cNvPr id="15" name="Rectangle 14"/>
-          <p:cNvSpPr/>
-          <p:nvPr/>
-        </p:nvSpPr>
-        <p:spPr>
-          <a:xfrm>
-            <a:off x="8412480" y="5212080"/>
-            <a:ext cx="3383280" cy="1143000"/>
-          </a:xfrm>
-          <a:prstGeom prst="rect">
-            <a:avLst/>
-          </a:prstGeom>
-          <a:solidFill>
-            <a:srgbClr val="FFFBF0"/>
-          </a:solidFill>
-          <a:ln w="9525">
-            <a:solidFill>
-              <a:srgbClr val="CCCCBB"/>
-            </a:solidFill>
-          </a:ln>
-        </p:spPr>
-        <p:style>
-          <a:lnRef idx="1">
-            <a:schemeClr val="accent1"/>
-          </a:lnRef>
-          <a:fillRef idx="3">
-            <a:schemeClr val="accent1"/>
-          </a:fillRef>
-          <a:effectRef idx="2">
-            <a:schemeClr val="accent1"/>
-          </a:effectRef>
-          <a:fontRef idx="minor">
-            <a:schemeClr val="lt1"/>
-          </a:fontRef>
-        </p:style>
-        <p:txBody>
-          <a:bodyPr rtlCol="0" anchor="ctr"/>
-          <a:lstStyle/>
-          <a:p>
-            <a:pPr algn="ctr"/>
-          </a:p>
-        </p:txBody>
-      </p:sp>
-      <p:sp>
-        <p:nvSpPr>
-          <p:cNvPr id="16" name="TextBox 15"/>
-          <p:cNvSpPr txBox="1"/>
-          <p:nvPr/>
-        </p:nvSpPr>
-        <p:spPr>
-          <a:xfrm>
-            <a:off x="8549640" y="5285232"/>
-            <a:ext cx="3108960" cy="365760"/>
-          </a:xfrm>
-          <a:prstGeom prst="rect">
-            <a:avLst/>
-          </a:prstGeom>
-          <a:noFill/>
-        </p:spPr>
-        <p:txBody>
-          <a:bodyPr wrap="square">
-            <a:spAutoFit/>
-          </a:bodyPr>
-          <a:lstStyle/>
-          <a:p>
-            <a:pPr algn="l"/>
-            <a:r>
-              <a:rPr sz="1400" b="1" i="0">
-                <a:solidFill>
-                  <a:srgbClr val="1A3D1A"/>
-                </a:solidFill>
-              </a:rPr>
-              <a:t>Time</a:t>
-            </a:r>
-          </a:p>
-        </p:txBody>
-      </p:sp>
-      <p:sp>
-        <p:nvSpPr>
-          <p:cNvPr id="17" name="TextBox 16"/>
-          <p:cNvSpPr txBox="1"/>
-          <p:nvPr/>
-        </p:nvSpPr>
-        <p:spPr>
-          <a:xfrm>
-            <a:off x="8549640" y="5623560"/>
-            <a:ext cx="3108960" cy="640080"/>
-          </a:xfrm>
-          <a:prstGeom prst="rect">
-            <a:avLst/>
-          </a:prstGeom>
-          <a:noFill/>
-        </p:spPr>
-        <p:txBody>
-          <a:bodyPr wrap="square">
-            <a:spAutoFit/>
-          </a:bodyPr>
-          <a:lstStyle/>
-          <a:p>
-            <a:pPr algn="l"/>
-            <a:r>
-              <a:rPr sz="1300" b="0" i="0">
-                <a:solidFill>
-                  <a:srgbClr val="1A1A1A"/>
-                </a:solidFill>
-              </a:rPr>
-              <a:t>&lt; 60 seconds for 1,000 games</a:t>
-            </a:r>
-          </a:p>
-        </p:txBody>
-      </p:sp>
+        </p:nvGraphicFramePr>
+        <p:xfrm>
+          <a:off x="365760" y="1188720"/>
+          <a:ext cx="11155680" cy="5120640"/>
+        </p:xfrm>
+        <a:graphic>
+          <a:graphicData uri="http://schemas.openxmlformats.org/drawingml/2006/table">
+            <a:tbl>
+              <a:tblPr firstRow="1" bandRow="1">
+                <a:tableStyleId>{5C22544A-7EE6-4342-B048-85BDC9FD1C3A}</a:tableStyleId>
+              </a:tblPr>
+              <a:tblGrid>
+                <a:gridCol w="2560320"/>
+                <a:gridCol w="4023360"/>
+                <a:gridCol w="4572000"/>
+              </a:tblGrid>
+              <a:tr h="731520">
+                <a:tc>
+                  <a:txBody>
+                    <a:bodyPr/>
+                    <a:lstStyle/>
+                    <a:p>
+                      <a:pPr algn="ctr"/>
+                      <a:r>
+                        <a:rPr b="1" sz="1500">
+                          <a:solidFill>
+                            <a:srgbClr val="FFFBF0"/>
+                          </a:solidFill>
+                        </a:rPr>
+                        <a:t>Full Rule</a:t>
+                      </a:r>
+                    </a:p>
+                  </a:txBody>
+                  <a:tcPr>
+                    <a:solidFill>
+                      <a:srgbClr val="1A3D1A"/>
+                    </a:solidFill>
+                  </a:tcPr>
+                </a:tc>
+                <a:tc>
+                  <a:txBody>
+                    <a:bodyPr/>
+                    <a:lstStyle/>
+                    <a:p>
+                      <a:pPr algn="ctr"/>
+                      <a:r>
+                        <a:rPr b="1" sz="1500">
+                          <a:solidFill>
+                            <a:srgbClr val="FFFBF0"/>
+                          </a:solidFill>
+                        </a:rPr>
+                        <a:t>Simulation Simplification</a:t>
+                      </a:r>
+                    </a:p>
+                  </a:txBody>
+                  <a:tcPr>
+                    <a:solidFill>
+                      <a:srgbClr val="1A3D1A"/>
+                    </a:solidFill>
+                  </a:tcPr>
+                </a:tc>
+                <a:tc>
+                  <a:txBody>
+                    <a:bodyPr/>
+                    <a:lstStyle/>
+                    <a:p>
+                      <a:pPr algn="ctr"/>
+                      <a:r>
+                        <a:rPr b="1" sz="1500">
+                          <a:solidFill>
+                            <a:srgbClr val="FFFBF0"/>
+                          </a:solidFill>
+                        </a:rPr>
+                        <a:t>Impact on Results</a:t>
+                      </a:r>
+                    </a:p>
+                  </a:txBody>
+                  <a:tcPr>
+                    <a:solidFill>
+                      <a:srgbClr val="1A3D1A"/>
+                    </a:solidFill>
+                  </a:tcPr>
+                </a:tc>
+              </a:tr>
+              <a:tr h="731520">
+                <a:tc>
+                  <a:txBody>
+                    <a:bodyPr/>
+                    <a:lstStyle/>
+                    <a:p>
+                      <a:pPr algn="l"/>
+                      <a:r>
+                        <a:rPr sz="1400">
+                          <a:solidFill>
+                            <a:srgbClr val="1A1A1A"/>
+                          </a:solidFill>
+                        </a:rPr>
+                        <a:t>Player-to-player trading</a:t>
+                      </a:r>
+                    </a:p>
+                  </a:txBody>
+                  <a:tcPr>
+                    <a:solidFill>
+                      <a:srgbClr val="FFFBF0"/>
+                    </a:solidFill>
+                  </a:tcPr>
+                </a:tc>
+                <a:tc>
+                  <a:txBody>
+                    <a:bodyPr/>
+                    <a:lstStyle/>
+                    <a:p>
+                      <a:pPr algn="l"/>
+                      <a:r>
+                        <a:rPr sz="1400">
+                          <a:solidFill>
+                            <a:srgbClr val="1A1A1A"/>
+                          </a:solidFill>
+                        </a:rPr>
+                        <a:t>Omitted — bank/port trading only</a:t>
+                      </a:r>
+                    </a:p>
+                  </a:txBody>
+                  <a:tcPr>
+                    <a:solidFill>
+                      <a:srgbClr val="FFFBF0"/>
+                    </a:solidFill>
+                  </a:tcPr>
+                </a:tc>
+                <a:tc>
+                  <a:txBody>
+                    <a:bodyPr/>
+                    <a:lstStyle/>
+                    <a:p>
+                      <a:pPr algn="l"/>
+                      <a:r>
+                        <a:rPr sz="1400">
+                          <a:solidFill>
+                            <a:srgbClr val="1A1A1A"/>
+                          </a:solidFill>
+                        </a:rPr>
+                        <a:t>Low: all strategies affected equally</a:t>
+                      </a:r>
+                    </a:p>
+                  </a:txBody>
+                  <a:tcPr>
+                    <a:solidFill>
+                      <a:srgbClr val="FFFBF0"/>
+                    </a:solidFill>
+                  </a:tcPr>
+                </a:tc>
+              </a:tr>
+              <a:tr h="731520">
+                <a:tc>
+                  <a:txBody>
+                    <a:bodyPr/>
+                    <a:lstStyle/>
+                    <a:p>
+                      <a:pPr algn="l"/>
+                      <a:r>
+                        <a:rPr sz="1400">
+                          <a:solidFill>
+                            <a:srgbClr val="1A1A1A"/>
+                          </a:solidFill>
+                        </a:rPr>
+                        <a:t>Longest Road</a:t>
+                      </a:r>
+                    </a:p>
+                  </a:txBody>
+                  <a:tcPr>
+                    <a:solidFill>
+                      <a:srgbClr val="E8F0E0"/>
+                    </a:solidFill>
+                  </a:tcPr>
+                </a:tc>
+                <a:tc>
+                  <a:txBody>
+                    <a:bodyPr/>
+                    <a:lstStyle/>
+                    <a:p>
+                      <a:pPr algn="l"/>
+                      <a:r>
+                        <a:rPr sz="1400">
+                          <a:solidFill>
+                            <a:srgbClr val="1A1A1A"/>
+                          </a:solidFill>
+                        </a:rPr>
+                        <a:t>Tracked; 2 VP at ≥5 road segments</a:t>
+                      </a:r>
+                    </a:p>
+                  </a:txBody>
+                  <a:tcPr>
+                    <a:solidFill>
+                      <a:srgbClr val="E8F0E0"/>
+                    </a:solidFill>
+                  </a:tcPr>
+                </a:tc>
+                <a:tc>
+                  <a:txBody>
+                    <a:bodyPr/>
+                    <a:lstStyle/>
+                    <a:p>
+                      <a:pPr algn="l"/>
+                      <a:r>
+                        <a:rPr sz="1400">
+                          <a:solidFill>
+                            <a:srgbClr val="1A1A1A"/>
+                          </a:solidFill>
+                        </a:rPr>
+                        <a:t>Faithful to rules</a:t>
+                      </a:r>
+                    </a:p>
+                  </a:txBody>
+                  <a:tcPr>
+                    <a:solidFill>
+                      <a:srgbClr val="E8F0E0"/>
+                    </a:solidFill>
+                  </a:tcPr>
+                </a:tc>
+              </a:tr>
+              <a:tr h="731520">
+                <a:tc>
+                  <a:txBody>
+                    <a:bodyPr/>
+                    <a:lstStyle/>
+                    <a:p>
+                      <a:pPr algn="l"/>
+                      <a:r>
+                        <a:rPr sz="1400">
+                          <a:solidFill>
+                            <a:srgbClr val="1A1A1A"/>
+                          </a:solidFill>
+                        </a:rPr>
+                        <a:t>Largest Army</a:t>
+                      </a:r>
+                    </a:p>
+                  </a:txBody>
+                  <a:tcPr>
+                    <a:solidFill>
+                      <a:srgbClr val="FFFBF0"/>
+                    </a:solidFill>
+                  </a:tcPr>
+                </a:tc>
+                <a:tc>
+                  <a:txBody>
+                    <a:bodyPr/>
+                    <a:lstStyle/>
+                    <a:p>
+                      <a:pPr algn="l"/>
+                      <a:r>
+                        <a:rPr sz="1400">
+                          <a:solidFill>
+                            <a:srgbClr val="1A1A1A"/>
+                          </a:solidFill>
+                        </a:rPr>
+                        <a:t>Tracked; 2 VP at ≥3 knights</a:t>
+                      </a:r>
+                    </a:p>
+                  </a:txBody>
+                  <a:tcPr>
+                    <a:solidFill>
+                      <a:srgbClr val="FFFBF0"/>
+                    </a:solidFill>
+                  </a:tcPr>
+                </a:tc>
+                <a:tc>
+                  <a:txBody>
+                    <a:bodyPr/>
+                    <a:lstStyle/>
+                    <a:p>
+                      <a:pPr algn="l"/>
+                      <a:r>
+                        <a:rPr sz="1400">
+                          <a:solidFill>
+                            <a:srgbClr val="1A1A1A"/>
+                          </a:solidFill>
+                        </a:rPr>
+                        <a:t>Faithful to rules</a:t>
+                      </a:r>
+                    </a:p>
+                  </a:txBody>
+                  <a:tcPr>
+                    <a:solidFill>
+                      <a:srgbClr val="FFFBF0"/>
+                    </a:solidFill>
+                  </a:tcPr>
+                </a:tc>
+              </a:tr>
+              <a:tr h="731520">
+                <a:tc>
+                  <a:txBody>
+                    <a:bodyPr/>
+                    <a:lstStyle/>
+                    <a:p>
+                      <a:pPr algn="l"/>
+                      <a:r>
+                        <a:rPr sz="1400">
+                          <a:solidFill>
+                            <a:srgbClr val="1A1A1A"/>
+                          </a:solidFill>
+                        </a:rPr>
+                        <a:t>Dev card variety</a:t>
+                      </a:r>
+                    </a:p>
+                  </a:txBody>
+                  <a:tcPr>
+                    <a:solidFill>
+                      <a:srgbClr val="E8F0E0"/>
+                    </a:solidFill>
+                  </a:tcPr>
+                </a:tc>
+                <a:tc>
+                  <a:txBody>
+                    <a:bodyPr/>
+                    <a:lstStyle/>
+                    <a:p>
+                      <a:pPr algn="l"/>
+                      <a:r>
+                        <a:rPr sz="1400">
+                          <a:solidFill>
+                            <a:srgbClr val="1A1A1A"/>
+                          </a:solidFill>
+                        </a:rPr>
+                        <a:t>Knights + VP cards; Progress cards stubbed</a:t>
+                      </a:r>
+                    </a:p>
+                  </a:txBody>
+                  <a:tcPr>
+                    <a:solidFill>
+                      <a:srgbClr val="E8F0E0"/>
+                    </a:solidFill>
+                  </a:tcPr>
+                </a:tc>
+                <a:tc>
+                  <a:txBody>
+                    <a:bodyPr/>
+                    <a:lstStyle/>
+                    <a:p>
+                      <a:pPr algn="l"/>
+                      <a:r>
+                        <a:rPr sz="1400">
+                          <a:solidFill>
+                            <a:srgbClr val="1A1A1A"/>
+                          </a:solidFill>
+                        </a:rPr>
+                        <a:t>Minor: removes Road Building / Monopoly edge cases</a:t>
+                      </a:r>
+                    </a:p>
+                  </a:txBody>
+                  <a:tcPr>
+                    <a:solidFill>
+                      <a:srgbClr val="E8F0E0"/>
+                    </a:solidFill>
+                  </a:tcPr>
+                </a:tc>
+              </a:tr>
+              <a:tr h="731520">
+                <a:tc>
+                  <a:txBody>
+                    <a:bodyPr/>
+                    <a:lstStyle/>
+                    <a:p>
+                      <a:pPr algn="l"/>
+                      <a:r>
+                        <a:rPr sz="1400">
+                          <a:solidFill>
+                            <a:srgbClr val="1A1A1A"/>
+                          </a:solidFill>
+                        </a:rPr>
+                        <a:t>Robber targeting</a:t>
+                      </a:r>
+                    </a:p>
+                  </a:txBody>
+                  <a:tcPr>
+                    <a:solidFill>
+                      <a:srgbClr val="FFFBF0"/>
+                    </a:solidFill>
+                  </a:tcPr>
+                </a:tc>
+                <a:tc>
+                  <a:txBody>
+                    <a:bodyPr/>
+                    <a:lstStyle/>
+                    <a:p>
+                      <a:pPr algn="l"/>
+                      <a:r>
+                        <a:rPr sz="1400">
+                          <a:solidFill>
+                            <a:srgbClr val="1A1A1A"/>
+                          </a:solidFill>
+                        </a:rPr>
+                        <a:t>Always targets the leading player (most VP)</a:t>
+                      </a:r>
+                    </a:p>
+                  </a:txBody>
+                  <a:tcPr>
+                    <a:solidFill>
+                      <a:srgbClr val="FFFBF0"/>
+                    </a:solidFill>
+                  </a:tcPr>
+                </a:tc>
+                <a:tc>
+                  <a:txBody>
+                    <a:bodyPr/>
+                    <a:lstStyle/>
+                    <a:p>
+                      <a:pPr algn="l"/>
+                      <a:r>
+                        <a:rPr sz="1400">
+                          <a:solidFill>
+                            <a:srgbClr val="1A1A1A"/>
+                          </a:solidFill>
+                        </a:rPr>
+                        <a:t>Deterministic; slightly penalises front-runners</a:t>
+                      </a:r>
+                    </a:p>
+                  </a:txBody>
+                  <a:tcPr>
+                    <a:solidFill>
+                      <a:srgbClr val="FFFBF0"/>
+                    </a:solidFill>
+                  </a:tcPr>
+                </a:tc>
+              </a:tr>
+              <a:tr h="731520">
+                <a:tc>
+                  <a:txBody>
+                    <a:bodyPr/>
+                    <a:lstStyle/>
+                    <a:p>
+                      <a:pPr algn="l"/>
+                      <a:r>
+                        <a:rPr sz="1400">
+                          <a:solidFill>
+                            <a:srgbClr val="1A1A1A"/>
+                          </a:solidFill>
+                        </a:rPr>
+                        <a:t>Board geometry</a:t>
+                      </a:r>
+                    </a:p>
+                  </a:txBody>
+                  <a:tcPr>
+                    <a:solidFill>
+                      <a:srgbClr val="E8F0E0"/>
+                    </a:solidFill>
+                  </a:tcPr>
+                </a:tc>
+                <a:tc>
+                  <a:txBody>
+                    <a:bodyPr/>
+                    <a:lstStyle/>
+                    <a:p>
+                      <a:pPr algn="l"/>
+                      <a:r>
+                        <a:rPr sz="1400">
+                          <a:solidFill>
+                            <a:srgbClr val="1A1A1A"/>
+                          </a:solidFill>
+                        </a:rPr>
+                        <a:t>Intersection IDs enumerated for simulation; not pixel-perfect</a:t>
+                      </a:r>
+                    </a:p>
+                  </a:txBody>
+                  <a:tcPr>
+                    <a:solidFill>
+                      <a:srgbClr val="E8F0E0"/>
+                    </a:solidFill>
+                  </a:tcPr>
+                </a:tc>
+                <a:tc>
+                  <a:txBody>
+                    <a:bodyPr/>
+                    <a:lstStyle/>
+                    <a:p>
+                      <a:pPr algn="l"/>
+                      <a:r>
+                        <a:rPr sz="1400">
+                          <a:solidFill>
+                            <a:srgbClr val="1A1A1A"/>
+                          </a:solidFill>
+                        </a:rPr>
+                        <a:t>Structural relationships preserved</a:t>
+                      </a:r>
+                    </a:p>
+                  </a:txBody>
+                  <a:tcPr>
+                    <a:solidFill>
+                      <a:srgbClr val="E8F0E0"/>
+                    </a:solidFill>
+                  </a:tcPr>
+                </a:tc>
+              </a:tr>
+            </a:tbl>
+          </a:graphicData>
+        </a:graphic>
+      </p:graphicFrame>
     </p:spTree>
   </p:cSld>
   <p:clrMapOvr>
@@ -4179,7 +4144,7 @@
                   <a:srgbClr val="FFFBF0"/>
                 </a:solidFill>
               </a:rPr>
-              <a:t>Results: Win Rates by Strategy</a:t>
+              <a:t>How to Run the Simulation</a:t>
             </a:r>
           </a:p>
         </p:txBody>
@@ -4192,18 +4157,18 @@
         </p:nvSpPr>
         <p:spPr>
           <a:xfrm>
-            <a:off x="457200" y="1143000"/>
-            <a:ext cx="11247120" cy="5029200"/>
+            <a:off x="365760" y="1188720"/>
+            <a:ext cx="7772400" cy="2926080"/>
           </a:xfrm>
           <a:prstGeom prst="rect">
             <a:avLst/>
           </a:prstGeom>
           <a:solidFill>
-            <a:srgbClr val="E8F2E0"/>
+            <a:srgbClr val="1A3D1A"/>
           </a:solidFill>
-          <a:ln w="25400">
+          <a:ln w="19050">
             <a:solidFill>
-              <a:srgbClr val="2E7D32"/>
+              <a:srgbClr val="8ECF3A"/>
             </a:solidFill>
           </a:ln>
         </p:spPr>
@@ -4237,8 +4202,8 @@
         </p:nvSpPr>
         <p:spPr>
           <a:xfrm>
-            <a:off x="457200" y="3200400"/>
-            <a:ext cx="11247120" cy="731520"/>
+            <a:off x="640080" y="1325880"/>
+            <a:ext cx="7315200" cy="2651760"/>
           </a:xfrm>
           <a:prstGeom prst="rect">
             <a:avLst/>
@@ -4251,28 +4216,79 @@
           </a:bodyPr>
           <a:lstStyle/>
           <a:p>
+            <a:pPr algn="l"/>
+            <a:r>
+              <a:rPr sz="1700" b="0" i="0">
+                <a:solidFill>
+                  <a:srgbClr val="8ECF3A"/>
+                </a:solidFill>
+              </a:rPr>
+              <a:t>source("R/simulation.R")
+results &lt;- run_simulation(
+    n_games = 1000,
+    seed    = 42
+)
+source("R/analysis.R")
+plot_win_rates(results)</a:t>
+            </a:r>
+          </a:p>
+        </p:txBody>
+      </p:sp>
+      <p:sp>
+        <p:nvSpPr>
+          <p:cNvPr id="6" name="Rectangle 5"/>
+          <p:cNvSpPr/>
+          <p:nvPr/>
+        </p:nvSpPr>
+        <p:spPr>
+          <a:xfrm>
+            <a:off x="8412480" y="1234440"/>
+            <a:ext cx="3383280" cy="1143000"/>
+          </a:xfrm>
+          <a:prstGeom prst="rect">
+            <a:avLst/>
+          </a:prstGeom>
+          <a:solidFill>
+            <a:srgbClr val="FFFBF0"/>
+          </a:solidFill>
+          <a:ln w="9525">
+            <a:solidFill>
+              <a:srgbClr val="CCCCBB"/>
+            </a:solidFill>
+          </a:ln>
+        </p:spPr>
+        <p:style>
+          <a:lnRef idx="1">
+            <a:schemeClr val="accent1"/>
+          </a:lnRef>
+          <a:fillRef idx="3">
+            <a:schemeClr val="accent1"/>
+          </a:fillRef>
+          <a:effectRef idx="2">
+            <a:schemeClr val="accent1"/>
+          </a:effectRef>
+          <a:fontRef idx="minor">
+            <a:schemeClr val="lt1"/>
+          </a:fontRef>
+        </p:style>
+        <p:txBody>
+          <a:bodyPr rtlCol="0" anchor="ctr"/>
+          <a:lstStyle/>
+          <a:p>
             <a:pPr algn="ctr"/>
-            <a:r>
-              <a:rPr sz="2200" b="1" i="0">
-                <a:solidFill>
-                  <a:srgbClr val="2E7D32"/>
-                </a:solidFill>
-              </a:rPr>
-              <a:t>[ Bar chart: win rate per strategy with 95% confidence intervals ]</a:t>
-            </a:r>
-          </a:p>
-        </p:txBody>
-      </p:sp>
-      <p:sp>
-        <p:nvSpPr>
-          <p:cNvPr id="6" name="TextBox 5"/>
+          </a:p>
+        </p:txBody>
+      </p:sp>
+      <p:sp>
+        <p:nvSpPr>
+          <p:cNvPr id="7" name="TextBox 6"/>
           <p:cNvSpPr txBox="1"/>
           <p:nvPr/>
         </p:nvSpPr>
         <p:spPr>
           <a:xfrm>
-            <a:off x="457200" y="4023360"/>
-            <a:ext cx="11247120" cy="548640"/>
+            <a:off x="8549640" y="1307592"/>
+            <a:ext cx="3108960" cy="365760"/>
           </a:xfrm>
           <a:prstGeom prst="rect">
             <a:avLst/>
@@ -4285,14 +4301,389 @@
           </a:bodyPr>
           <a:lstStyle/>
           <a:p>
+            <a:pPr algn="l"/>
+            <a:r>
+              <a:rPr sz="1400" b="1" i="0">
+                <a:solidFill>
+                  <a:srgbClr val="1A3D1A"/>
+                </a:solidFill>
+              </a:rPr>
+              <a:t>Output</a:t>
+            </a:r>
+          </a:p>
+        </p:txBody>
+      </p:sp>
+      <p:sp>
+        <p:nvSpPr>
+          <p:cNvPr id="8" name="TextBox 7"/>
+          <p:cNvSpPr txBox="1"/>
+          <p:nvPr/>
+        </p:nvSpPr>
+        <p:spPr>
+          <a:xfrm>
+            <a:off x="8549640" y="1645920"/>
+            <a:ext cx="3108960" cy="640080"/>
+          </a:xfrm>
+          <a:prstGeom prst="rect">
+            <a:avLst/>
+          </a:prstGeom>
+          <a:noFill/>
+        </p:spPr>
+        <p:txBody>
+          <a:bodyPr wrap="square">
+            <a:spAutoFit/>
+          </a:bodyPr>
+          <a:lstStyle/>
+          <a:p>
+            <a:pPr algn="l"/>
+            <a:r>
+              <a:rPr sz="1300" b="0" i="0">
+                <a:solidFill>
+                  <a:srgbClr val="1A1A1A"/>
+                </a:solidFill>
+              </a:rPr>
+              <a:t>results/simulation_results.csv</a:t>
+            </a:r>
+          </a:p>
+        </p:txBody>
+      </p:sp>
+      <p:sp>
+        <p:nvSpPr>
+          <p:cNvPr id="9" name="Rectangle 8"/>
+          <p:cNvSpPr/>
+          <p:nvPr/>
+        </p:nvSpPr>
+        <p:spPr>
+          <a:xfrm>
+            <a:off x="8412480" y="2560320"/>
+            <a:ext cx="3383280" cy="1143000"/>
+          </a:xfrm>
+          <a:prstGeom prst="rect">
+            <a:avLst/>
+          </a:prstGeom>
+          <a:solidFill>
+            <a:srgbClr val="FFFBF0"/>
+          </a:solidFill>
+          <a:ln w="9525">
+            <a:solidFill>
+              <a:srgbClr val="CCCCBB"/>
+            </a:solidFill>
+          </a:ln>
+        </p:spPr>
+        <p:style>
+          <a:lnRef idx="1">
+            <a:schemeClr val="accent1"/>
+          </a:lnRef>
+          <a:fillRef idx="3">
+            <a:schemeClr val="accent1"/>
+          </a:fillRef>
+          <a:effectRef idx="2">
+            <a:schemeClr val="accent1"/>
+          </a:effectRef>
+          <a:fontRef idx="minor">
+            <a:schemeClr val="lt1"/>
+          </a:fontRef>
+        </p:style>
+        <p:txBody>
+          <a:bodyPr rtlCol="0" anchor="ctr"/>
+          <a:lstStyle/>
+          <a:p>
             <a:pPr algn="ctr"/>
-            <a:r>
-              <a:rPr sz="1500" b="0" i="1">
-                <a:solidFill>
-                  <a:srgbClr val="555555"/>
-                </a:solidFill>
-              </a:rPr>
-              <a:t>Source: results/simulation_results.csv  ·  n = 1,000 games  ·  seed = 42</a:t>
+          </a:p>
+        </p:txBody>
+      </p:sp>
+      <p:sp>
+        <p:nvSpPr>
+          <p:cNvPr id="10" name="TextBox 9"/>
+          <p:cNvSpPr txBox="1"/>
+          <p:nvPr/>
+        </p:nvSpPr>
+        <p:spPr>
+          <a:xfrm>
+            <a:off x="8549640" y="2633472"/>
+            <a:ext cx="3108960" cy="365760"/>
+          </a:xfrm>
+          <a:prstGeom prst="rect">
+            <a:avLst/>
+          </a:prstGeom>
+          <a:noFill/>
+        </p:spPr>
+        <p:txBody>
+          <a:bodyPr wrap="square">
+            <a:spAutoFit/>
+          </a:bodyPr>
+          <a:lstStyle/>
+          <a:p>
+            <a:pPr algn="l"/>
+            <a:r>
+              <a:rPr sz="1400" b="1" i="0">
+                <a:solidFill>
+                  <a:srgbClr val="1A3D1A"/>
+                </a:solidFill>
+              </a:rPr>
+              <a:t>Charts</a:t>
+            </a:r>
+          </a:p>
+        </p:txBody>
+      </p:sp>
+      <p:sp>
+        <p:nvSpPr>
+          <p:cNvPr id="11" name="TextBox 10"/>
+          <p:cNvSpPr txBox="1"/>
+          <p:nvPr/>
+        </p:nvSpPr>
+        <p:spPr>
+          <a:xfrm>
+            <a:off x="8549640" y="2971800"/>
+            <a:ext cx="3108960" cy="640080"/>
+          </a:xfrm>
+          <a:prstGeom prst="rect">
+            <a:avLst/>
+          </a:prstGeom>
+          <a:noFill/>
+        </p:spPr>
+        <p:txBody>
+          <a:bodyPr wrap="square">
+            <a:spAutoFit/>
+          </a:bodyPr>
+          <a:lstStyle/>
+          <a:p>
+            <a:pPr algn="l"/>
+            <a:r>
+              <a:rPr sz="1300" b="0" i="0">
+                <a:solidFill>
+                  <a:srgbClr val="1A1A1A"/>
+                </a:solidFill>
+              </a:rPr>
+              <a:t>Win rate bar chart with 95% CIs
+VP distribution violin/boxplot</a:t>
+            </a:r>
+          </a:p>
+        </p:txBody>
+      </p:sp>
+      <p:sp>
+        <p:nvSpPr>
+          <p:cNvPr id="12" name="Rectangle 11"/>
+          <p:cNvSpPr/>
+          <p:nvPr/>
+        </p:nvSpPr>
+        <p:spPr>
+          <a:xfrm>
+            <a:off x="8412480" y="3886200"/>
+            <a:ext cx="3383280" cy="1143000"/>
+          </a:xfrm>
+          <a:prstGeom prst="rect">
+            <a:avLst/>
+          </a:prstGeom>
+          <a:solidFill>
+            <a:srgbClr val="FFFBF0"/>
+          </a:solidFill>
+          <a:ln w="9525">
+            <a:solidFill>
+              <a:srgbClr val="CCCCBB"/>
+            </a:solidFill>
+          </a:ln>
+        </p:spPr>
+        <p:style>
+          <a:lnRef idx="1">
+            <a:schemeClr val="accent1"/>
+          </a:lnRef>
+          <a:fillRef idx="3">
+            <a:schemeClr val="accent1"/>
+          </a:fillRef>
+          <a:effectRef idx="2">
+            <a:schemeClr val="accent1"/>
+          </a:effectRef>
+          <a:fontRef idx="minor">
+            <a:schemeClr val="lt1"/>
+          </a:fontRef>
+        </p:style>
+        <p:txBody>
+          <a:bodyPr rtlCol="0" anchor="ctr"/>
+          <a:lstStyle/>
+          <a:p>
+            <a:pPr algn="ctr"/>
+          </a:p>
+        </p:txBody>
+      </p:sp>
+      <p:sp>
+        <p:nvSpPr>
+          <p:cNvPr id="13" name="TextBox 12"/>
+          <p:cNvSpPr txBox="1"/>
+          <p:nvPr/>
+        </p:nvSpPr>
+        <p:spPr>
+          <a:xfrm>
+            <a:off x="8549640" y="3959352"/>
+            <a:ext cx="3108960" cy="365760"/>
+          </a:xfrm>
+          <a:prstGeom prst="rect">
+            <a:avLst/>
+          </a:prstGeom>
+          <a:noFill/>
+        </p:spPr>
+        <p:txBody>
+          <a:bodyPr wrap="square">
+            <a:spAutoFit/>
+          </a:bodyPr>
+          <a:lstStyle/>
+          <a:p>
+            <a:pPr algn="l"/>
+            <a:r>
+              <a:rPr sz="1400" b="1" i="0">
+                <a:solidFill>
+                  <a:srgbClr val="1A3D1A"/>
+                </a:solidFill>
+              </a:rPr>
+              <a:t>Stats</a:t>
+            </a:r>
+          </a:p>
+        </p:txBody>
+      </p:sp>
+      <p:sp>
+        <p:nvSpPr>
+          <p:cNvPr id="14" name="TextBox 13"/>
+          <p:cNvSpPr txBox="1"/>
+          <p:nvPr/>
+        </p:nvSpPr>
+        <p:spPr>
+          <a:xfrm>
+            <a:off x="8549640" y="4297680"/>
+            <a:ext cx="3108960" cy="640080"/>
+          </a:xfrm>
+          <a:prstGeom prst="rect">
+            <a:avLst/>
+          </a:prstGeom>
+          <a:noFill/>
+        </p:spPr>
+        <p:txBody>
+          <a:bodyPr wrap="square">
+            <a:spAutoFit/>
+          </a:bodyPr>
+          <a:lstStyle/>
+          <a:p>
+            <a:pPr algn="l"/>
+            <a:r>
+              <a:rPr sz="1300" b="0" i="0">
+                <a:solidFill>
+                  <a:srgbClr val="1A1A1A"/>
+                </a:solidFill>
+              </a:rPr>
+              <a:t>χ² test on win-count table
+Target: p &lt; 0.05</a:t>
+            </a:r>
+          </a:p>
+        </p:txBody>
+      </p:sp>
+      <p:sp>
+        <p:nvSpPr>
+          <p:cNvPr id="15" name="Rectangle 14"/>
+          <p:cNvSpPr/>
+          <p:nvPr/>
+        </p:nvSpPr>
+        <p:spPr>
+          <a:xfrm>
+            <a:off x="8412480" y="5212080"/>
+            <a:ext cx="3383280" cy="1143000"/>
+          </a:xfrm>
+          <a:prstGeom prst="rect">
+            <a:avLst/>
+          </a:prstGeom>
+          <a:solidFill>
+            <a:srgbClr val="FFFBF0"/>
+          </a:solidFill>
+          <a:ln w="9525">
+            <a:solidFill>
+              <a:srgbClr val="CCCCBB"/>
+            </a:solidFill>
+          </a:ln>
+        </p:spPr>
+        <p:style>
+          <a:lnRef idx="1">
+            <a:schemeClr val="accent1"/>
+          </a:lnRef>
+          <a:fillRef idx="3">
+            <a:schemeClr val="accent1"/>
+          </a:fillRef>
+          <a:effectRef idx="2">
+            <a:schemeClr val="accent1"/>
+          </a:effectRef>
+          <a:fontRef idx="minor">
+            <a:schemeClr val="lt1"/>
+          </a:fontRef>
+        </p:style>
+        <p:txBody>
+          <a:bodyPr rtlCol="0" anchor="ctr"/>
+          <a:lstStyle/>
+          <a:p>
+            <a:pPr algn="ctr"/>
+          </a:p>
+        </p:txBody>
+      </p:sp>
+      <p:sp>
+        <p:nvSpPr>
+          <p:cNvPr id="16" name="TextBox 15"/>
+          <p:cNvSpPr txBox="1"/>
+          <p:nvPr/>
+        </p:nvSpPr>
+        <p:spPr>
+          <a:xfrm>
+            <a:off x="8549640" y="5285232"/>
+            <a:ext cx="3108960" cy="365760"/>
+          </a:xfrm>
+          <a:prstGeom prst="rect">
+            <a:avLst/>
+          </a:prstGeom>
+          <a:noFill/>
+        </p:spPr>
+        <p:txBody>
+          <a:bodyPr wrap="square">
+            <a:spAutoFit/>
+          </a:bodyPr>
+          <a:lstStyle/>
+          <a:p>
+            <a:pPr algn="l"/>
+            <a:r>
+              <a:rPr sz="1400" b="1" i="0">
+                <a:solidFill>
+                  <a:srgbClr val="1A3D1A"/>
+                </a:solidFill>
+              </a:rPr>
+              <a:t>Time</a:t>
+            </a:r>
+          </a:p>
+        </p:txBody>
+      </p:sp>
+      <p:sp>
+        <p:nvSpPr>
+          <p:cNvPr id="17" name="TextBox 16"/>
+          <p:cNvSpPr txBox="1"/>
+          <p:nvPr/>
+        </p:nvSpPr>
+        <p:spPr>
+          <a:xfrm>
+            <a:off x="8549640" y="5623560"/>
+            <a:ext cx="3108960" cy="640080"/>
+          </a:xfrm>
+          <a:prstGeom prst="rect">
+            <a:avLst/>
+          </a:prstGeom>
+          <a:noFill/>
+        </p:spPr>
+        <p:txBody>
+          <a:bodyPr wrap="square">
+            <a:spAutoFit/>
+          </a:bodyPr>
+          <a:lstStyle/>
+          <a:p>
+            <a:pPr algn="l"/>
+            <a:r>
+              <a:rPr sz="1300" b="0" i="0">
+                <a:solidFill>
+                  <a:srgbClr val="1A1A1A"/>
+                </a:solidFill>
+              </a:rPr>
+              <a:t>&lt; 60 seconds for 1,000 games</a:t>
             </a:r>
           </a:p>
         </p:txBody>
@@ -4395,7 +4786,7 @@
                   <a:srgbClr val="FFFBF0"/>
                 </a:solidFill>
               </a:rPr>
-              <a:t>Results: VP Distribution at Game End</a:t>
+              <a:t>Results: Win Rates by Strategy</a:t>
             </a:r>
           </a:p>
         </p:txBody>
@@ -4474,7 +4865,7 @@
                   <a:srgbClr val="2E7D32"/>
                 </a:solidFill>
               </a:rPr>
-              <a:t>[ Violin / boxplot: final VP per strategy across all games ]</a:t>
+              <a:t>[ Bar chart: win rate per strategy with 95% confidence intervals ]</a:t>
             </a:r>
           </a:p>
         </p:txBody>
@@ -4611,7 +5002,7 @@
                   <a:srgbClr val="FFFBF0"/>
                 </a:solidFill>
               </a:rPr>
-              <a:t>Statistical Analysis</a:t>
+              <a:t>Results: VP Distribution at Game End</a:t>
             </a:r>
           </a:p>
         </p:txBody>
@@ -4690,7 +5081,7 @@
                   <a:srgbClr val="2E7D32"/>
                 </a:solidFill>
               </a:rPr>
-              <a:t>[ χ² test output: observed vs. expected win counts, p-value, conclusion ]</a:t>
+              <a:t>[ Violin / boxplot: final VP per strategy across all games ]</a:t>
             </a:r>
           </a:p>
         </p:txBody>
@@ -4724,7 +5115,7 @@
                   <a:srgbClr val="555555"/>
                 </a:solidFill>
               </a:rPr>
-              <a:t>Success criterion: p &lt; 0.05  ·  null hypothesis: all strategies win equally often</a:t>
+              <a:t>Source: results/simulation_results.csv  ·  n = 1,000 games  ·  seed = 42</a:t>
             </a:r>
           </a:p>
         </p:txBody>
@@ -4770,6 +5161,222 @@
             <a:avLst/>
           </a:prstGeom>
           <a:solidFill>
+            <a:srgbClr val="2E7D32"/>
+          </a:solidFill>
+          <a:ln>
+            <a:noFill/>
+          </a:ln>
+        </p:spPr>
+        <p:style>
+          <a:lnRef idx="1">
+            <a:schemeClr val="accent1"/>
+          </a:lnRef>
+          <a:fillRef idx="3">
+            <a:schemeClr val="accent1"/>
+          </a:fillRef>
+          <a:effectRef idx="2">
+            <a:schemeClr val="accent1"/>
+          </a:effectRef>
+          <a:fontRef idx="minor">
+            <a:schemeClr val="lt1"/>
+          </a:fontRef>
+        </p:style>
+        <p:txBody>
+          <a:bodyPr rtlCol="0" anchor="ctr"/>
+          <a:lstStyle/>
+          <a:p>
+            <a:pPr algn="ctr"/>
+          </a:p>
+        </p:txBody>
+      </p:sp>
+      <p:sp>
+        <p:nvSpPr>
+          <p:cNvPr id="3" name="TextBox 2"/>
+          <p:cNvSpPr txBox="1"/>
+          <p:nvPr/>
+        </p:nvSpPr>
+        <p:spPr>
+          <a:xfrm>
+            <a:off x="365760" y="109728"/>
+            <a:ext cx="11430000" cy="822960"/>
+          </a:xfrm>
+          <a:prstGeom prst="rect">
+            <a:avLst/>
+          </a:prstGeom>
+          <a:noFill/>
+        </p:spPr>
+        <p:txBody>
+          <a:bodyPr wrap="square">
+            <a:spAutoFit/>
+          </a:bodyPr>
+          <a:lstStyle/>
+          <a:p>
+            <a:pPr algn="l"/>
+            <a:r>
+              <a:rPr sz="3200" b="1" i="0">
+                <a:solidFill>
+                  <a:srgbClr val="FFFBF0"/>
+                </a:solidFill>
+              </a:rPr>
+              <a:t>Statistical Analysis</a:t>
+            </a:r>
+          </a:p>
+        </p:txBody>
+      </p:sp>
+      <p:sp>
+        <p:nvSpPr>
+          <p:cNvPr id="4" name="Rectangle 3"/>
+          <p:cNvSpPr/>
+          <p:nvPr/>
+        </p:nvSpPr>
+        <p:spPr>
+          <a:xfrm>
+            <a:off x="457200" y="1143000"/>
+            <a:ext cx="11247120" cy="5029200"/>
+          </a:xfrm>
+          <a:prstGeom prst="rect">
+            <a:avLst/>
+          </a:prstGeom>
+          <a:solidFill>
+            <a:srgbClr val="E8F2E0"/>
+          </a:solidFill>
+          <a:ln w="25400">
+            <a:solidFill>
+              <a:srgbClr val="2E7D32"/>
+            </a:solidFill>
+          </a:ln>
+        </p:spPr>
+        <p:style>
+          <a:lnRef idx="1">
+            <a:schemeClr val="accent1"/>
+          </a:lnRef>
+          <a:fillRef idx="3">
+            <a:schemeClr val="accent1"/>
+          </a:fillRef>
+          <a:effectRef idx="2">
+            <a:schemeClr val="accent1"/>
+          </a:effectRef>
+          <a:fontRef idx="minor">
+            <a:schemeClr val="lt1"/>
+          </a:fontRef>
+        </p:style>
+        <p:txBody>
+          <a:bodyPr rtlCol="0" anchor="ctr"/>
+          <a:lstStyle/>
+          <a:p>
+            <a:pPr algn="ctr"/>
+          </a:p>
+        </p:txBody>
+      </p:sp>
+      <p:sp>
+        <p:nvSpPr>
+          <p:cNvPr id="5" name="TextBox 4"/>
+          <p:cNvSpPr txBox="1"/>
+          <p:nvPr/>
+        </p:nvSpPr>
+        <p:spPr>
+          <a:xfrm>
+            <a:off x="457200" y="3200400"/>
+            <a:ext cx="11247120" cy="731520"/>
+          </a:xfrm>
+          <a:prstGeom prst="rect">
+            <a:avLst/>
+          </a:prstGeom>
+          <a:noFill/>
+        </p:spPr>
+        <p:txBody>
+          <a:bodyPr wrap="square">
+            <a:spAutoFit/>
+          </a:bodyPr>
+          <a:lstStyle/>
+          <a:p>
+            <a:pPr algn="ctr"/>
+            <a:r>
+              <a:rPr sz="2200" b="1" i="0">
+                <a:solidFill>
+                  <a:srgbClr val="2E7D32"/>
+                </a:solidFill>
+              </a:rPr>
+              <a:t>[ χ² test output: observed vs. expected win counts, p-value, conclusion ]</a:t>
+            </a:r>
+          </a:p>
+        </p:txBody>
+      </p:sp>
+      <p:sp>
+        <p:nvSpPr>
+          <p:cNvPr id="6" name="TextBox 5"/>
+          <p:cNvSpPr txBox="1"/>
+          <p:nvPr/>
+        </p:nvSpPr>
+        <p:spPr>
+          <a:xfrm>
+            <a:off x="457200" y="4023360"/>
+            <a:ext cx="11247120" cy="548640"/>
+          </a:xfrm>
+          <a:prstGeom prst="rect">
+            <a:avLst/>
+          </a:prstGeom>
+          <a:noFill/>
+        </p:spPr>
+        <p:txBody>
+          <a:bodyPr wrap="square">
+            <a:spAutoFit/>
+          </a:bodyPr>
+          <a:lstStyle/>
+          <a:p>
+            <a:pPr algn="ctr"/>
+            <a:r>
+              <a:rPr sz="1500" b="0" i="1">
+                <a:solidFill>
+                  <a:srgbClr val="555555"/>
+                </a:solidFill>
+              </a:rPr>
+              <a:t>Success criterion: p &lt; 0.05  ·  null hypothesis: all strategies win equally often</a:t>
+            </a:r>
+          </a:p>
+        </p:txBody>
+      </p:sp>
+    </p:spTree>
+  </p:cSld>
+  <p:clrMapOvr>
+    <a:masterClrMapping/>
+  </p:clrMapOvr>
+</p:sld>
+</file>
+
+<file path=ppt/slides/slide15.xml><?xml version="1.0" encoding="utf-8"?>
+<p:sld xmlns:a="http://schemas.openxmlformats.org/drawingml/2006/main" xmlns:p="http://schemas.openxmlformats.org/presentationml/2006/main" xmlns:r="http://schemas.openxmlformats.org/officeDocument/2006/relationships">
+  <p:cSld>
+    <p:bg>
+      <p:bgPr>
+        <a:solidFill>
+          <a:srgbClr val="F5F5F0"/>
+        </a:solidFill>
+        <a:effectLst/>
+      </p:bgPr>
+    </p:bg>
+    <p:spTree>
+      <p:nvGrpSpPr>
+        <p:cNvPr id="1" name=""/>
+        <p:cNvGrpSpPr/>
+        <p:nvPr/>
+      </p:nvGrpSpPr>
+      <p:grpSpPr/>
+      <p:sp>
+        <p:nvSpPr>
+          <p:cNvPr id="2" name="Rectangle 1"/>
+          <p:cNvSpPr/>
+          <p:nvPr/>
+        </p:nvSpPr>
+        <p:spPr>
+          <a:xfrm>
+            <a:off x="0" y="0"/>
+            <a:ext cx="12188952" cy="1005840"/>
+          </a:xfrm>
+          <a:prstGeom prst="rect">
+            <a:avLst/>
+          </a:prstGeom>
+          <a:solidFill>
             <a:srgbClr val="1A3D1A"/>
           </a:solidFill>
           <a:ln>
@@ -5001,7 +5608,7 @@
 </p:sld>
 </file>
 
-<file path=ppt/slides/slide15.xml><?xml version="1.0" encoding="utf-8"?>
+<file path=ppt/slides/slide16.xml><?xml version="1.0" encoding="utf-8"?>
 <p:sld xmlns:a="http://schemas.openxmlformats.org/drawingml/2006/main" xmlns:p="http://schemas.openxmlformats.org/presentationml/2006/main" xmlns:r="http://schemas.openxmlformats.org/officeDocument/2006/relationships">
   <p:cSld>
     <p:bg>
@@ -8047,200 +8654,35 @@
                   <a:srgbClr val="FFFBF0"/>
                 </a:solidFill>
               </a:rPr>
-              <a:t>Architecture: 6 R Modules</a:t>
-            </a:r>
-          </a:p>
-        </p:txBody>
-      </p:sp>
-      <p:sp>
-        <p:nvSpPr>
-          <p:cNvPr id="4" name="Rectangle 3"/>
-          <p:cNvSpPr/>
+              <a:t>Example Board (seed = 42)</a:t>
+            </a:r>
+          </a:p>
+        </p:txBody>
+      </p:sp>
+      <p:pic>
+        <p:nvPicPr>
+          <p:cNvPr id="4" name="Picture 3" descr="example_board.png"/>
+          <p:cNvPicPr>
+            <a:picLocks noChangeAspect="1"/>
+          </p:cNvPicPr>
           <p:nvPr/>
-        </p:nvSpPr>
-        <p:spPr>
-          <a:xfrm>
-            <a:off x="274320" y="1143000"/>
-            <a:ext cx="11612880" cy="5394960"/>
+        </p:nvPicPr>
+        <p:blipFill>
+          <a:blip r:embed="rId2"/>
+          <a:stretch>
+            <a:fillRect/>
+          </a:stretch>
+        </p:blipFill>
+        <p:spPr>
+          <a:xfrm>
+            <a:off x="3305556" y="1097280"/>
+            <a:ext cx="5577840" cy="5577840"/>
           </a:xfrm>
           <a:prstGeom prst="rect">
             <a:avLst/>
           </a:prstGeom>
-          <a:solidFill>
-            <a:srgbClr val="FFFBF0"/>
-          </a:solidFill>
-          <a:ln w="9525">
-            <a:solidFill>
-              <a:srgbClr val="CCCCBB"/>
-            </a:solidFill>
-          </a:ln>
-        </p:spPr>
-        <p:style>
-          <a:lnRef idx="1">
-            <a:schemeClr val="accent1"/>
-          </a:lnRef>
-          <a:fillRef idx="3">
-            <a:schemeClr val="accent1"/>
-          </a:fillRef>
-          <a:effectRef idx="2">
-            <a:schemeClr val="accent1"/>
-          </a:effectRef>
-          <a:fontRef idx="minor">
-            <a:schemeClr val="lt1"/>
-          </a:fontRef>
-        </p:style>
-        <p:txBody>
-          <a:bodyPr rtlCol="0" anchor="ctr"/>
-          <a:lstStyle/>
-          <a:p>
-            <a:pPr algn="ctr"/>
-          </a:p>
-        </p:txBody>
-      </p:sp>
-      <p:sp>
-        <p:nvSpPr>
-          <p:cNvPr id="5" name="TextBox 4"/>
-          <p:cNvSpPr txBox="1"/>
-          <p:nvPr/>
-        </p:nvSpPr>
-        <p:spPr>
-          <a:xfrm>
-            <a:off x="502920" y="1280160"/>
-            <a:ext cx="11155680" cy="5120640"/>
-          </a:xfrm>
-          <a:prstGeom prst="rect">
-            <a:avLst/>
-          </a:prstGeom>
-          <a:noFill/>
-        </p:spPr>
-        <p:txBody>
-          <a:bodyPr wrap="square">
-            <a:spAutoFit/>
-          </a:bodyPr>
-          <a:lstStyle/>
-          <a:p>
-            <a:pPr/>
-            <a:r>
-              <a:rPr sz="2000" b="1">
-                <a:solidFill>
-                  <a:srgbClr val="1A3D1A"/>
-                </a:solidFill>
-              </a:rPr>
-              <a:t>▸  board.R — Hex graph, board generation, ports</a:t>
-            </a:r>
-          </a:p>
-          <a:p>
-            <a:pPr lvl="1"/>
-            <a:r>
-              <a:rPr sz="1700" b="0">
-                <a:solidFill>
-                  <a:srgbClr val="1A1A1A"/>
-                </a:solidFill>
-              </a:rPr>
-              <a:t>     •  19 hexes · 54 intersections · 72 road edges · axial coordinate layout</a:t>
-            </a:r>
-          </a:p>
-          <a:p>
-            <a:pPr lvl="1"/>
-            <a:r>
-              <a:rPr sz="1700" b="0">
-                <a:solidFill>
-                  <a:srgbClr val="1A1A1A"/>
-                </a:solidFill>
-              </a:rPr>
-              <a:t>     •  generate_board() supports random terrain, tokens, and ports</a:t>
-            </a:r>
-          </a:p>
-          <a:p>
-            <a:pPr/>
-            <a:r>
-              <a:rPr sz="2000" b="1">
-                <a:solidFill>
-                  <a:srgbClr val="1A3D1A"/>
-                </a:solidFill>
-              </a:rPr>
-              <a:t>▸  player.R — Player state and resource management</a:t>
-            </a:r>
-          </a:p>
-          <a:p>
-            <a:pPr lvl="1"/>
-            <a:r>
-              <a:rPr sz="1700" b="0">
-                <a:solidFill>
-                  <a:srgbClr val="1A1A1A"/>
-                </a:solidFill>
-              </a:rPr>
-              <a:t>     •  Resource cards, settlements, cities, roads, dev cards, VP</a:t>
-            </a:r>
-          </a:p>
-          <a:p>
-            <a:pPr lvl="1"/>
-            <a:r>
-              <a:rPr sz="1700" b="0">
-                <a:solidFill>
-                  <a:srgbClr val="1A1A1A"/>
-                </a:solidFill>
-              </a:rPr>
-              <a:t>     •  can_build() / do_build() / do_trade() helpers; 7-card discard rule</a:t>
-            </a:r>
-          </a:p>
-          <a:p>
-            <a:pPr/>
-            <a:r>
-              <a:rPr sz="2000" b="1">
-                <a:solidFill>
-                  <a:srgbClr val="1A3D1A"/>
-                </a:solidFill>
-              </a:rPr>
-              <a:t>▸  strategy.R — Strategy interface + implementations</a:t>
-            </a:r>
-          </a:p>
-          <a:p>
-            <a:pPr lvl="1"/>
-            <a:r>
-              <a:rPr sz="1700" b="0">
-                <a:solidFill>
-                  <a:srgbClr val="1A1A1A"/>
-                </a:solidFill>
-              </a:rPr>
-              <a:t>     •  Each strategy is a named list of functions: choose_initial_placement, choose_road_placement, choose_action</a:t>
-            </a:r>
-          </a:p>
-          <a:p>
-            <a:pPr/>
-            <a:r>
-              <a:rPr sz="2000" b="1">
-                <a:solidFill>
-                  <a:srgbClr val="1A3D1A"/>
-                </a:solidFill>
-              </a:rPr>
-              <a:t>▸  game.R — Single game loop (reverse snake draft → turns → win check)</a:t>
-            </a:r>
-          </a:p>
-          <a:p>
-            <a:pPr/>
-            <a:r>
-              <a:rPr sz="2000" b="1">
-                <a:solidFill>
-                  <a:srgbClr val="1A3D1A"/>
-                </a:solidFill>
-              </a:rPr>
-              <a:t>▸  simulation.R — Monte Carlo runner: run_simulation(n_games, seed)</a:t>
-            </a:r>
-          </a:p>
-          <a:p>
-            <a:pPr/>
-            <a:r>
-              <a:rPr sz="2000" b="1">
-                <a:solidFill>
-                  <a:srgbClr val="1A3D1A"/>
-                </a:solidFill>
-              </a:rPr>
-              <a:t>▸  analysis.R — ggplot2 charts + chi-squared significance test</a:t>
-            </a:r>
-          </a:p>
-        </p:txBody>
-      </p:sp>
+        </p:spPr>
+      </p:pic>
     </p:spTree>
   </p:cSld>
   <p:clrMapOvr>
@@ -8339,7 +8781,7 @@
                   <a:srgbClr val="FFFBF0"/>
                 </a:solidFill>
               </a:rPr>
-              <a:t>Game Loop (game.R)</a:t>
+              <a:t>Architecture: 6 R Modules</a:t>
             </a:r>
           </a:p>
         </p:txBody>
@@ -8418,7 +8860,7 @@
                   <a:srgbClr val="1A3D1A"/>
                 </a:solidFill>
               </a:rPr>
-              <a:t>▸  Initial placement — reverse snake draft</a:t>
+              <a:t>▸  board.R — Hex graph, board generation, ports</a:t>
             </a:r>
           </a:p>
           <a:p>
@@ -8429,7 +8871,7 @@
                   <a:srgbClr val="1A1A1A"/>
                 </a:solidFill>
               </a:rPr>
-              <a:t>     •  P1 → P2 → P3 → P4 → P4 → P3 → P2 → P1</a:t>
+              <a:t>     •  19 hexes · 54 intersections · 72 road edges · axial coordinate layout</a:t>
             </a:r>
           </a:p>
           <a:p>
@@ -8440,7 +8882,7 @@
                   <a:srgbClr val="1A1A1A"/>
                 </a:solidFill>
               </a:rPr>
-              <a:t>     •  Second settlement grants 1 of each adjacent resource to start</a:t>
+              <a:t>     •  generate_board() supports random terrain, tokens, and ports</a:t>
             </a:r>
           </a:p>
           <a:p>
@@ -8451,7 +8893,7 @@
                   <a:srgbClr val="1A3D1A"/>
                 </a:solidFill>
               </a:rPr>
-              <a:t>▸  Each turn: Roll → Robber/Production → Trade → Build</a:t>
+              <a:t>▸  player.R — Player state and resource management</a:t>
             </a:r>
           </a:p>
           <a:p>
@@ -8462,7 +8904,7 @@
                   <a:srgbClr val="1A1A1A"/>
                 </a:solidFill>
               </a:rPr>
-              <a:t>     •  Roll 7: discard rule (&gt;7 cards) + robber targets the leading player</a:t>
+              <a:t>     •  Resource cards, settlements, cities, roads, dev cards, VP</a:t>
             </a:r>
           </a:p>
           <a:p>
@@ -8473,7 +8915,18 @@
                   <a:srgbClr val="1A1A1A"/>
                 </a:solidFill>
               </a:rPr>
-              <a:t>     •  Production: settlements yield 1 resource, cities yield 2</a:t>
+              <a:t>     •  can_build() / do_build() / do_trade() helpers; 7-card discard rule</a:t>
+            </a:r>
+          </a:p>
+          <a:p>
+            <a:pPr/>
+            <a:r>
+              <a:rPr sz="2000" b="1">
+                <a:solidFill>
+                  <a:srgbClr val="1A3D1A"/>
+                </a:solidFill>
+              </a:rPr>
+              <a:t>▸  strategy.R — Strategy interface + implementations</a:t>
             </a:r>
           </a:p>
           <a:p>
@@ -8484,7 +8937,7 @@
                   <a:srgbClr val="1A1A1A"/>
                 </a:solidFill>
               </a:rPr>
-              <a:t>     •  Trade: bank 4:1 or port rates (3:1 general / 2:1 specific)</a:t>
+              <a:t>     •  Each strategy is a named list of functions: choose_initial_placement, choose_road_placement, choose_action</a:t>
             </a:r>
           </a:p>
           <a:p>
@@ -8495,18 +8948,7 @@
                   <a:srgbClr val="1A3D1A"/>
                 </a:solidFill>
               </a:rPr>
-              <a:t>▸  Win condition: first player to reach 10 VP on their turn</a:t>
-            </a:r>
-          </a:p>
-          <a:p>
-            <a:pPr lvl="1"/>
-            <a:r>
-              <a:rPr sz="1700" b="0">
-                <a:solidFill>
-                  <a:srgbClr val="1A1A1A"/>
-                </a:solidFill>
-              </a:rPr>
-              <a:t>     •  Stalemate safeguard: game ends after 200 turns (recorded as NA winner)</a:t>
+              <a:t>▸  game.R — Single game loop (reverse snake draft → turns → win check)</a:t>
             </a:r>
           </a:p>
           <a:p>
@@ -8517,29 +8959,18 @@
                   <a:srgbClr val="1A3D1A"/>
                 </a:solidFill>
               </a:rPr>
-              <a:t>▸  Special VP bonuses tracked each turn</a:t>
-            </a:r>
-          </a:p>
-          <a:p>
-            <a:pPr lvl="1"/>
-            <a:r>
-              <a:rPr sz="1700" b="0">
-                <a:solidFill>
-                  <a:srgbClr val="1A1A1A"/>
-                </a:solidFill>
-              </a:rPr>
-              <a:t>     •  Longest Road (≥ 5 segments) → 2 VP</a:t>
-            </a:r>
-          </a:p>
-          <a:p>
-            <a:pPr lvl="1"/>
-            <a:r>
-              <a:rPr sz="1700" b="0">
-                <a:solidFill>
-                  <a:srgbClr val="1A1A1A"/>
-                </a:solidFill>
-              </a:rPr>
-              <a:t>     •  Largest Army (≥ 3 knights) → 2 VP</a:t>
+              <a:t>▸  simulation.R — Monte Carlo runner: run_simulation(n_games, seed)</a:t>
+            </a:r>
+          </a:p>
+          <a:p>
+            <a:pPr/>
+            <a:r>
+              <a:rPr sz="2000" b="1">
+                <a:solidFill>
+                  <a:srgbClr val="1A3D1A"/>
+                </a:solidFill>
+              </a:rPr>
+              <a:t>▸  analysis.R — ggplot2 charts + chi-squared significance test</a:t>
             </a:r>
           </a:p>
         </p:txBody>
@@ -8642,514 +9073,211 @@
                   <a:srgbClr val="FFFBF0"/>
                 </a:solidFill>
               </a:rPr>
-              <a:t>Simplifications vs. Full Catan Rules</a:t>
-            </a:r>
-          </a:p>
-        </p:txBody>
-      </p:sp>
-      <p:graphicFrame>
-        <p:nvGraphicFramePr>
-          <p:cNvPr id="4" name="Table 3"/>
-          <p:cNvGraphicFramePr>
-            <a:graphicFrameLocks noGrp="1"/>
-          </p:cNvGraphicFramePr>
+              <a:t>Game Loop (game.R)</a:t>
+            </a:r>
+          </a:p>
+        </p:txBody>
+      </p:sp>
+      <p:sp>
+        <p:nvSpPr>
+          <p:cNvPr id="4" name="Rectangle 3"/>
+          <p:cNvSpPr/>
           <p:nvPr/>
-        </p:nvGraphicFramePr>
-        <p:xfrm>
-          <a:off x="365760" y="1188720"/>
-          <a:ext cx="11155680" cy="5120640"/>
-        </p:xfrm>
-        <a:graphic>
-          <a:graphicData uri="http://schemas.openxmlformats.org/drawingml/2006/table">
-            <a:tbl>
-              <a:tblPr firstRow="1" bandRow="1">
-                <a:tableStyleId>{5C22544A-7EE6-4342-B048-85BDC9FD1C3A}</a:tableStyleId>
-              </a:tblPr>
-              <a:tblGrid>
-                <a:gridCol w="2560320"/>
-                <a:gridCol w="4023360"/>
-                <a:gridCol w="4572000"/>
-              </a:tblGrid>
-              <a:tr h="731520">
-                <a:tc>
-                  <a:txBody>
-                    <a:bodyPr/>
-                    <a:lstStyle/>
-                    <a:p>
-                      <a:pPr algn="ctr"/>
-                      <a:r>
-                        <a:rPr b="1" sz="1500">
-                          <a:solidFill>
-                            <a:srgbClr val="FFFBF0"/>
-                          </a:solidFill>
-                        </a:rPr>
-                        <a:t>Full Rule</a:t>
-                      </a:r>
-                    </a:p>
-                  </a:txBody>
-                  <a:tcPr>
-                    <a:solidFill>
-                      <a:srgbClr val="1A3D1A"/>
-                    </a:solidFill>
-                  </a:tcPr>
-                </a:tc>
-                <a:tc>
-                  <a:txBody>
-                    <a:bodyPr/>
-                    <a:lstStyle/>
-                    <a:p>
-                      <a:pPr algn="ctr"/>
-                      <a:r>
-                        <a:rPr b="1" sz="1500">
-                          <a:solidFill>
-                            <a:srgbClr val="FFFBF0"/>
-                          </a:solidFill>
-                        </a:rPr>
-                        <a:t>Simulation Simplification</a:t>
-                      </a:r>
-                    </a:p>
-                  </a:txBody>
-                  <a:tcPr>
-                    <a:solidFill>
-                      <a:srgbClr val="1A3D1A"/>
-                    </a:solidFill>
-                  </a:tcPr>
-                </a:tc>
-                <a:tc>
-                  <a:txBody>
-                    <a:bodyPr/>
-                    <a:lstStyle/>
-                    <a:p>
-                      <a:pPr algn="ctr"/>
-                      <a:r>
-                        <a:rPr b="1" sz="1500">
-                          <a:solidFill>
-                            <a:srgbClr val="FFFBF0"/>
-                          </a:solidFill>
-                        </a:rPr>
-                        <a:t>Impact on Results</a:t>
-                      </a:r>
-                    </a:p>
-                  </a:txBody>
-                  <a:tcPr>
-                    <a:solidFill>
-                      <a:srgbClr val="1A3D1A"/>
-                    </a:solidFill>
-                  </a:tcPr>
-                </a:tc>
-              </a:tr>
-              <a:tr h="731520">
-                <a:tc>
-                  <a:txBody>
-                    <a:bodyPr/>
-                    <a:lstStyle/>
-                    <a:p>
-                      <a:pPr algn="l"/>
-                      <a:r>
-                        <a:rPr sz="1400">
-                          <a:solidFill>
-                            <a:srgbClr val="1A1A1A"/>
-                          </a:solidFill>
-                        </a:rPr>
-                        <a:t>Player-to-player trading</a:t>
-                      </a:r>
-                    </a:p>
-                  </a:txBody>
-                  <a:tcPr>
-                    <a:solidFill>
-                      <a:srgbClr val="FFFBF0"/>
-                    </a:solidFill>
-                  </a:tcPr>
-                </a:tc>
-                <a:tc>
-                  <a:txBody>
-                    <a:bodyPr/>
-                    <a:lstStyle/>
-                    <a:p>
-                      <a:pPr algn="l"/>
-                      <a:r>
-                        <a:rPr sz="1400">
-                          <a:solidFill>
-                            <a:srgbClr val="1A1A1A"/>
-                          </a:solidFill>
-                        </a:rPr>
-                        <a:t>Omitted — bank/port trading only</a:t>
-                      </a:r>
-                    </a:p>
-                  </a:txBody>
-                  <a:tcPr>
-                    <a:solidFill>
-                      <a:srgbClr val="FFFBF0"/>
-                    </a:solidFill>
-                  </a:tcPr>
-                </a:tc>
-                <a:tc>
-                  <a:txBody>
-                    <a:bodyPr/>
-                    <a:lstStyle/>
-                    <a:p>
-                      <a:pPr algn="l"/>
-                      <a:r>
-                        <a:rPr sz="1400">
-                          <a:solidFill>
-                            <a:srgbClr val="1A1A1A"/>
-                          </a:solidFill>
-                        </a:rPr>
-                        <a:t>Low: all strategies affected equally</a:t>
-                      </a:r>
-                    </a:p>
-                  </a:txBody>
-                  <a:tcPr>
-                    <a:solidFill>
-                      <a:srgbClr val="FFFBF0"/>
-                    </a:solidFill>
-                  </a:tcPr>
-                </a:tc>
-              </a:tr>
-              <a:tr h="731520">
-                <a:tc>
-                  <a:txBody>
-                    <a:bodyPr/>
-                    <a:lstStyle/>
-                    <a:p>
-                      <a:pPr algn="l"/>
-                      <a:r>
-                        <a:rPr sz="1400">
-                          <a:solidFill>
-                            <a:srgbClr val="1A1A1A"/>
-                          </a:solidFill>
-                        </a:rPr>
-                        <a:t>Longest Road</a:t>
-                      </a:r>
-                    </a:p>
-                  </a:txBody>
-                  <a:tcPr>
-                    <a:solidFill>
-                      <a:srgbClr val="E8F0E0"/>
-                    </a:solidFill>
-                  </a:tcPr>
-                </a:tc>
-                <a:tc>
-                  <a:txBody>
-                    <a:bodyPr/>
-                    <a:lstStyle/>
-                    <a:p>
-                      <a:pPr algn="l"/>
-                      <a:r>
-                        <a:rPr sz="1400">
-                          <a:solidFill>
-                            <a:srgbClr val="1A1A1A"/>
-                          </a:solidFill>
-                        </a:rPr>
-                        <a:t>Tracked; 2 VP at ≥5 road segments</a:t>
-                      </a:r>
-                    </a:p>
-                  </a:txBody>
-                  <a:tcPr>
-                    <a:solidFill>
-                      <a:srgbClr val="E8F0E0"/>
-                    </a:solidFill>
-                  </a:tcPr>
-                </a:tc>
-                <a:tc>
-                  <a:txBody>
-                    <a:bodyPr/>
-                    <a:lstStyle/>
-                    <a:p>
-                      <a:pPr algn="l"/>
-                      <a:r>
-                        <a:rPr sz="1400">
-                          <a:solidFill>
-                            <a:srgbClr val="1A1A1A"/>
-                          </a:solidFill>
-                        </a:rPr>
-                        <a:t>Faithful to rules</a:t>
-                      </a:r>
-                    </a:p>
-                  </a:txBody>
-                  <a:tcPr>
-                    <a:solidFill>
-                      <a:srgbClr val="E8F0E0"/>
-                    </a:solidFill>
-                  </a:tcPr>
-                </a:tc>
-              </a:tr>
-              <a:tr h="731520">
-                <a:tc>
-                  <a:txBody>
-                    <a:bodyPr/>
-                    <a:lstStyle/>
-                    <a:p>
-                      <a:pPr algn="l"/>
-                      <a:r>
-                        <a:rPr sz="1400">
-                          <a:solidFill>
-                            <a:srgbClr val="1A1A1A"/>
-                          </a:solidFill>
-                        </a:rPr>
-                        <a:t>Largest Army</a:t>
-                      </a:r>
-                    </a:p>
-                  </a:txBody>
-                  <a:tcPr>
-                    <a:solidFill>
-                      <a:srgbClr val="FFFBF0"/>
-                    </a:solidFill>
-                  </a:tcPr>
-                </a:tc>
-                <a:tc>
-                  <a:txBody>
-                    <a:bodyPr/>
-                    <a:lstStyle/>
-                    <a:p>
-                      <a:pPr algn="l"/>
-                      <a:r>
-                        <a:rPr sz="1400">
-                          <a:solidFill>
-                            <a:srgbClr val="1A1A1A"/>
-                          </a:solidFill>
-                        </a:rPr>
-                        <a:t>Tracked; 2 VP at ≥3 knights</a:t>
-                      </a:r>
-                    </a:p>
-                  </a:txBody>
-                  <a:tcPr>
-                    <a:solidFill>
-                      <a:srgbClr val="FFFBF0"/>
-                    </a:solidFill>
-                  </a:tcPr>
-                </a:tc>
-                <a:tc>
-                  <a:txBody>
-                    <a:bodyPr/>
-                    <a:lstStyle/>
-                    <a:p>
-                      <a:pPr algn="l"/>
-                      <a:r>
-                        <a:rPr sz="1400">
-                          <a:solidFill>
-                            <a:srgbClr val="1A1A1A"/>
-                          </a:solidFill>
-                        </a:rPr>
-                        <a:t>Faithful to rules</a:t>
-                      </a:r>
-                    </a:p>
-                  </a:txBody>
-                  <a:tcPr>
-                    <a:solidFill>
-                      <a:srgbClr val="FFFBF0"/>
-                    </a:solidFill>
-                  </a:tcPr>
-                </a:tc>
-              </a:tr>
-              <a:tr h="731520">
-                <a:tc>
-                  <a:txBody>
-                    <a:bodyPr/>
-                    <a:lstStyle/>
-                    <a:p>
-                      <a:pPr algn="l"/>
-                      <a:r>
-                        <a:rPr sz="1400">
-                          <a:solidFill>
-                            <a:srgbClr val="1A1A1A"/>
-                          </a:solidFill>
-                        </a:rPr>
-                        <a:t>Dev card variety</a:t>
-                      </a:r>
-                    </a:p>
-                  </a:txBody>
-                  <a:tcPr>
-                    <a:solidFill>
-                      <a:srgbClr val="E8F0E0"/>
-                    </a:solidFill>
-                  </a:tcPr>
-                </a:tc>
-                <a:tc>
-                  <a:txBody>
-                    <a:bodyPr/>
-                    <a:lstStyle/>
-                    <a:p>
-                      <a:pPr algn="l"/>
-                      <a:r>
-                        <a:rPr sz="1400">
-                          <a:solidFill>
-                            <a:srgbClr val="1A1A1A"/>
-                          </a:solidFill>
-                        </a:rPr>
-                        <a:t>Knights + VP cards; Progress cards stubbed</a:t>
-                      </a:r>
-                    </a:p>
-                  </a:txBody>
-                  <a:tcPr>
-                    <a:solidFill>
-                      <a:srgbClr val="E8F0E0"/>
-                    </a:solidFill>
-                  </a:tcPr>
-                </a:tc>
-                <a:tc>
-                  <a:txBody>
-                    <a:bodyPr/>
-                    <a:lstStyle/>
-                    <a:p>
-                      <a:pPr algn="l"/>
-                      <a:r>
-                        <a:rPr sz="1400">
-                          <a:solidFill>
-                            <a:srgbClr val="1A1A1A"/>
-                          </a:solidFill>
-                        </a:rPr>
-                        <a:t>Minor: removes Road Building / Monopoly edge cases</a:t>
-                      </a:r>
-                    </a:p>
-                  </a:txBody>
-                  <a:tcPr>
-                    <a:solidFill>
-                      <a:srgbClr val="E8F0E0"/>
-                    </a:solidFill>
-                  </a:tcPr>
-                </a:tc>
-              </a:tr>
-              <a:tr h="731520">
-                <a:tc>
-                  <a:txBody>
-                    <a:bodyPr/>
-                    <a:lstStyle/>
-                    <a:p>
-                      <a:pPr algn="l"/>
-                      <a:r>
-                        <a:rPr sz="1400">
-                          <a:solidFill>
-                            <a:srgbClr val="1A1A1A"/>
-                          </a:solidFill>
-                        </a:rPr>
-                        <a:t>Robber targeting</a:t>
-                      </a:r>
-                    </a:p>
-                  </a:txBody>
-                  <a:tcPr>
-                    <a:solidFill>
-                      <a:srgbClr val="FFFBF0"/>
-                    </a:solidFill>
-                  </a:tcPr>
-                </a:tc>
-                <a:tc>
-                  <a:txBody>
-                    <a:bodyPr/>
-                    <a:lstStyle/>
-                    <a:p>
-                      <a:pPr algn="l"/>
-                      <a:r>
-                        <a:rPr sz="1400">
-                          <a:solidFill>
-                            <a:srgbClr val="1A1A1A"/>
-                          </a:solidFill>
-                        </a:rPr>
-                        <a:t>Always targets the leading player (most VP)</a:t>
-                      </a:r>
-                    </a:p>
-                  </a:txBody>
-                  <a:tcPr>
-                    <a:solidFill>
-                      <a:srgbClr val="FFFBF0"/>
-                    </a:solidFill>
-                  </a:tcPr>
-                </a:tc>
-                <a:tc>
-                  <a:txBody>
-                    <a:bodyPr/>
-                    <a:lstStyle/>
-                    <a:p>
-                      <a:pPr algn="l"/>
-                      <a:r>
-                        <a:rPr sz="1400">
-                          <a:solidFill>
-                            <a:srgbClr val="1A1A1A"/>
-                          </a:solidFill>
-                        </a:rPr>
-                        <a:t>Deterministic; slightly penalises front-runners</a:t>
-                      </a:r>
-                    </a:p>
-                  </a:txBody>
-                  <a:tcPr>
-                    <a:solidFill>
-                      <a:srgbClr val="FFFBF0"/>
-                    </a:solidFill>
-                  </a:tcPr>
-                </a:tc>
-              </a:tr>
-              <a:tr h="731520">
-                <a:tc>
-                  <a:txBody>
-                    <a:bodyPr/>
-                    <a:lstStyle/>
-                    <a:p>
-                      <a:pPr algn="l"/>
-                      <a:r>
-                        <a:rPr sz="1400">
-                          <a:solidFill>
-                            <a:srgbClr val="1A1A1A"/>
-                          </a:solidFill>
-                        </a:rPr>
-                        <a:t>Board geometry</a:t>
-                      </a:r>
-                    </a:p>
-                  </a:txBody>
-                  <a:tcPr>
-                    <a:solidFill>
-                      <a:srgbClr val="E8F0E0"/>
-                    </a:solidFill>
-                  </a:tcPr>
-                </a:tc>
-                <a:tc>
-                  <a:txBody>
-                    <a:bodyPr/>
-                    <a:lstStyle/>
-                    <a:p>
-                      <a:pPr algn="l"/>
-                      <a:r>
-                        <a:rPr sz="1400">
-                          <a:solidFill>
-                            <a:srgbClr val="1A1A1A"/>
-                          </a:solidFill>
-                        </a:rPr>
-                        <a:t>Intersection IDs enumerated for simulation; not pixel-perfect</a:t>
-                      </a:r>
-                    </a:p>
-                  </a:txBody>
-                  <a:tcPr>
-                    <a:solidFill>
-                      <a:srgbClr val="E8F0E0"/>
-                    </a:solidFill>
-                  </a:tcPr>
-                </a:tc>
-                <a:tc>
-                  <a:txBody>
-                    <a:bodyPr/>
-                    <a:lstStyle/>
-                    <a:p>
-                      <a:pPr algn="l"/>
-                      <a:r>
-                        <a:rPr sz="1400">
-                          <a:solidFill>
-                            <a:srgbClr val="1A1A1A"/>
-                          </a:solidFill>
-                        </a:rPr>
-                        <a:t>Structural relationships preserved</a:t>
-                      </a:r>
-                    </a:p>
-                  </a:txBody>
-                  <a:tcPr>
-                    <a:solidFill>
-                      <a:srgbClr val="E8F0E0"/>
-                    </a:solidFill>
-                  </a:tcPr>
-                </a:tc>
-              </a:tr>
-            </a:tbl>
-          </a:graphicData>
-        </a:graphic>
-      </p:graphicFrame>
+        </p:nvSpPr>
+        <p:spPr>
+          <a:xfrm>
+            <a:off x="274320" y="1143000"/>
+            <a:ext cx="11612880" cy="5394960"/>
+          </a:xfrm>
+          <a:prstGeom prst="rect">
+            <a:avLst/>
+          </a:prstGeom>
+          <a:solidFill>
+            <a:srgbClr val="FFFBF0"/>
+          </a:solidFill>
+          <a:ln w="9525">
+            <a:solidFill>
+              <a:srgbClr val="CCCCBB"/>
+            </a:solidFill>
+          </a:ln>
+        </p:spPr>
+        <p:style>
+          <a:lnRef idx="1">
+            <a:schemeClr val="accent1"/>
+          </a:lnRef>
+          <a:fillRef idx="3">
+            <a:schemeClr val="accent1"/>
+          </a:fillRef>
+          <a:effectRef idx="2">
+            <a:schemeClr val="accent1"/>
+          </a:effectRef>
+          <a:fontRef idx="minor">
+            <a:schemeClr val="lt1"/>
+          </a:fontRef>
+        </p:style>
+        <p:txBody>
+          <a:bodyPr rtlCol="0" anchor="ctr"/>
+          <a:lstStyle/>
+          <a:p>
+            <a:pPr algn="ctr"/>
+          </a:p>
+        </p:txBody>
+      </p:sp>
+      <p:sp>
+        <p:nvSpPr>
+          <p:cNvPr id="5" name="TextBox 4"/>
+          <p:cNvSpPr txBox="1"/>
+          <p:nvPr/>
+        </p:nvSpPr>
+        <p:spPr>
+          <a:xfrm>
+            <a:off x="502920" y="1280160"/>
+            <a:ext cx="11155680" cy="5120640"/>
+          </a:xfrm>
+          <a:prstGeom prst="rect">
+            <a:avLst/>
+          </a:prstGeom>
+          <a:noFill/>
+        </p:spPr>
+        <p:txBody>
+          <a:bodyPr wrap="square">
+            <a:spAutoFit/>
+          </a:bodyPr>
+          <a:lstStyle/>
+          <a:p>
+            <a:pPr/>
+            <a:r>
+              <a:rPr sz="2000" b="1">
+                <a:solidFill>
+                  <a:srgbClr val="1A3D1A"/>
+                </a:solidFill>
+              </a:rPr>
+              <a:t>▸  Initial placement — reverse snake draft</a:t>
+            </a:r>
+          </a:p>
+          <a:p>
+            <a:pPr lvl="1"/>
+            <a:r>
+              <a:rPr sz="1700" b="0">
+                <a:solidFill>
+                  <a:srgbClr val="1A1A1A"/>
+                </a:solidFill>
+              </a:rPr>
+              <a:t>     •  P1 → P2 → P3 → P4 → P4 → P3 → P2 → P1</a:t>
+            </a:r>
+          </a:p>
+          <a:p>
+            <a:pPr lvl="1"/>
+            <a:r>
+              <a:rPr sz="1700" b="0">
+                <a:solidFill>
+                  <a:srgbClr val="1A1A1A"/>
+                </a:solidFill>
+              </a:rPr>
+              <a:t>     •  Second settlement grants 1 of each adjacent resource to start</a:t>
+            </a:r>
+          </a:p>
+          <a:p>
+            <a:pPr/>
+            <a:r>
+              <a:rPr sz="2000" b="1">
+                <a:solidFill>
+                  <a:srgbClr val="1A3D1A"/>
+                </a:solidFill>
+              </a:rPr>
+              <a:t>▸  Each turn: Roll → Robber/Production → Trade → Build</a:t>
+            </a:r>
+          </a:p>
+          <a:p>
+            <a:pPr lvl="1"/>
+            <a:r>
+              <a:rPr sz="1700" b="0">
+                <a:solidFill>
+                  <a:srgbClr val="1A1A1A"/>
+                </a:solidFill>
+              </a:rPr>
+              <a:t>     •  Roll 7: discard rule (&gt;7 cards) + robber targets the leading player</a:t>
+            </a:r>
+          </a:p>
+          <a:p>
+            <a:pPr lvl="1"/>
+            <a:r>
+              <a:rPr sz="1700" b="0">
+                <a:solidFill>
+                  <a:srgbClr val="1A1A1A"/>
+                </a:solidFill>
+              </a:rPr>
+              <a:t>     •  Production: settlements yield 1 resource, cities yield 2</a:t>
+            </a:r>
+          </a:p>
+          <a:p>
+            <a:pPr lvl="1"/>
+            <a:r>
+              <a:rPr sz="1700" b="0">
+                <a:solidFill>
+                  <a:srgbClr val="1A1A1A"/>
+                </a:solidFill>
+              </a:rPr>
+              <a:t>     •  Trade: bank 4:1 or port rates (3:1 general / 2:1 specific)</a:t>
+            </a:r>
+          </a:p>
+          <a:p>
+            <a:pPr/>
+            <a:r>
+              <a:rPr sz="2000" b="1">
+                <a:solidFill>
+                  <a:srgbClr val="1A3D1A"/>
+                </a:solidFill>
+              </a:rPr>
+              <a:t>▸  Win condition: first player to reach 10 VP on their turn</a:t>
+            </a:r>
+          </a:p>
+          <a:p>
+            <a:pPr lvl="1"/>
+            <a:r>
+              <a:rPr sz="1700" b="0">
+                <a:solidFill>
+                  <a:srgbClr val="1A1A1A"/>
+                </a:solidFill>
+              </a:rPr>
+              <a:t>     •  Stalemate safeguard: game ends after 200 turns (recorded as NA winner)</a:t>
+            </a:r>
+          </a:p>
+          <a:p>
+            <a:pPr/>
+            <a:r>
+              <a:rPr sz="2000" b="1">
+                <a:solidFill>
+                  <a:srgbClr val="1A3D1A"/>
+                </a:solidFill>
+              </a:rPr>
+              <a:t>▸  Special VP bonuses tracked each turn</a:t>
+            </a:r>
+          </a:p>
+          <a:p>
+            <a:pPr lvl="1"/>
+            <a:r>
+              <a:rPr sz="1700" b="0">
+                <a:solidFill>
+                  <a:srgbClr val="1A1A1A"/>
+                </a:solidFill>
+              </a:rPr>
+              <a:t>     •  Longest Road (≥ 5 segments) → 2 VP</a:t>
+            </a:r>
+          </a:p>
+          <a:p>
+            <a:pPr lvl="1"/>
+            <a:r>
+              <a:rPr sz="1700" b="0">
+                <a:solidFill>
+                  <a:srgbClr val="1A1A1A"/>
+                </a:solidFill>
+              </a:rPr>
+              <a:t>     •  Largest Army (≥ 3 knights) → 2 VP</a:t>
+            </a:r>
+          </a:p>
+        </p:txBody>
+      </p:sp>
     </p:spTree>
   </p:cSld>
   <p:clrMapOvr>

</xml_diff>